<commit_message>
Add Team Codexa details to deck, README and license
Co-Authored-By: Claude Opus 5.5 <noreply@anthropic.com>
</commit_message>
<xml_diff>
--- a/deck/SmartIrrigate_Deck.pptx
+++ b/deck/SmartIrrigate_Deck.pptx
@@ -3678,7 +3678,7 @@
         </p:nvSpPr>
         <p:spPr>
           <a:xfrm>
-            <a:off x="548640" y="3931920"/>
+            <a:off x="548640" y="3749039"/>
             <a:ext cx="10515600" cy="457200"/>
           </a:xfrm>
           <a:prstGeom prst="rect">
@@ -3698,13 +3698,13 @@
               </a:spcAft>
             </a:pPr>
             <a:r>
-              <a:rPr sz="2000" b="1">
+              <a:rPr sz="2200" b="1">
                 <a:solidFill>
                   <a:srgbClr val="FFFFFF"/>
                 </a:solidFill>
                 <a:latin typeface="Calibri"/>
               </a:rPr>
-              <a:t>[TEAM NAME]   [MEMBERS]</a:t>
+              <a:t>Team Codexa</a:t>
             </a:r>
           </a:p>
         </p:txBody>
@@ -3717,7 +3717,7 @@
         </p:nvSpPr>
         <p:spPr>
           <a:xfrm>
-            <a:off x="548640" y="4434840"/>
+            <a:off x="548640" y="4206240"/>
             <a:ext cx="10515600" cy="457200"/>
           </a:xfrm>
           <a:prstGeom prst="rect">
@@ -3737,6 +3737,45 @@
               </a:spcAft>
             </a:pPr>
             <a:r>
+              <a:rPr sz="1800" b="0">
+                <a:solidFill>
+                  <a:srgbClr val="FFFFFF"/>
+                </a:solidFill>
+                <a:latin typeface="Calibri"/>
+              </a:rPr>
+              <a:t>Vedanshi Goyal  ·  Apoorva Singh  ·  Soumyadip Manna  ·  Pranay Maheshwari</a:t>
+            </a:r>
+          </a:p>
+        </p:txBody>
+      </p:sp>
+      <p:sp>
+        <p:nvSpPr>
+          <p:cNvPr id="6" name="TextBox 5"/>
+          <p:cNvSpPr txBox="1"/>
+          <p:nvPr/>
+        </p:nvSpPr>
+        <p:spPr>
+          <a:xfrm>
+            <a:off x="548640" y="4800600"/>
+            <a:ext cx="10515600" cy="457200"/>
+          </a:xfrm>
+          <a:prstGeom prst="rect">
+            <a:avLst/>
+          </a:prstGeom>
+          <a:noFill/>
+        </p:spPr>
+        <p:txBody>
+          <a:bodyPr wrap="square" anchor="t" lIns="45720" rIns="45720">
+            <a:spAutoFit/>
+          </a:bodyPr>
+          <a:lstStyle/>
+          <a:p>
+            <a:pPr algn="l">
+              <a:spcAft>
+                <a:spcPts val="600"/>
+              </a:spcAft>
+            </a:pPr>
+            <a:r>
               <a:rPr sz="1600" b="0">
                 <a:solidFill>
                   <a:srgbClr val="D9E8CC"/>
@@ -3750,7 +3789,7 @@
       </p:sp>
       <p:sp>
         <p:nvSpPr>
-          <p:cNvPr id="6" name="TextBox 5"/>
+          <p:cNvPr id="7" name="TextBox 6"/>
           <p:cNvSpPr txBox="1"/>
           <p:nvPr/>
         </p:nvSpPr>

</xml_diff>

<commit_message>
Deck: add repository link to title slide
Co-Authored-By: Claude Opus 5.5 <noreply@anthropic.com>
</commit_message>
<xml_diff>
--- a/deck/SmartIrrigate_Deck.pptx
+++ b/deck/SmartIrrigate_Deck.pptx
@@ -3790,6 +3790,45 @@
       <p:sp>
         <p:nvSpPr>
           <p:cNvPr id="7" name="TextBox 6"/>
+          <p:cNvSpPr txBox="1"/>
+          <p:nvPr/>
+        </p:nvSpPr>
+        <p:spPr>
+          <a:xfrm>
+            <a:off x="548640" y="5212080"/>
+            <a:ext cx="10515600" cy="457200"/>
+          </a:xfrm>
+          <a:prstGeom prst="rect">
+            <a:avLst/>
+          </a:prstGeom>
+          <a:noFill/>
+        </p:spPr>
+        <p:txBody>
+          <a:bodyPr wrap="square" anchor="t" lIns="45720" rIns="45720">
+            <a:spAutoFit/>
+          </a:bodyPr>
+          <a:lstStyle/>
+          <a:p>
+            <a:pPr algn="l">
+              <a:spcAft>
+                <a:spcPts val="600"/>
+              </a:spcAft>
+            </a:pPr>
+            <a:r>
+              <a:rPr sz="1600" b="0">
+                <a:solidFill>
+                  <a:srgbClr val="FFFFFF"/>
+                </a:solidFill>
+                <a:latin typeface="Calibri"/>
+              </a:rPr>
+              <a:t>Code: https://github.com/vedanshigoyal/ecologic-hackathon</a:t>
+            </a:r>
+          </a:p>
+        </p:txBody>
+      </p:sp>
+      <p:sp>
+        <p:nvSpPr>
+          <p:cNvPr id="8" name="TextBox 7"/>
           <p:cNvSpPr txBox="1"/>
           <p:nvPr/>
         </p:nvSpPr>

</xml_diff>